<commit_message>
built phase 6, 7, 8 : A* path
</commit_message>
<xml_diff>
--- a/IntelliBot_MidTerm_Review.pptx
+++ b/IntelliBot_MidTerm_Review.pptx
@@ -2582,7 +2582,7 @@
                 <a:ea typeface="Segoe UI" pitchFamily="34" charset="-122"/>
                 <a:cs typeface="Segoe UI" pitchFamily="34" charset="-120"/>
               </a:rPr>
-              <a:t>Complete P0 codebase: world generator, custom robot, planner, controller, FSM — 63 unit tests green.</a:t>
+              <a:t>Complete P0 codebase driven in Webots: the full FSM mission ran FIND → NAVIGATE → PICK → PLAN → DELIVER → DONE (181 s, cross-track max 6.3 cm).</a:t>
             </a:r>
             <a:endParaRPr lang="en-US" sz="1700" dirty="0"/>
           </a:p>
@@ -2603,7 +2603,7 @@
                 <a:ea typeface="Segoe UI" pitchFamily="34" charset="-122"/>
                 <a:cs typeface="Segoe UI" pitchFamily="34" charset="-120"/>
               </a:rPr>
-              <a:t>Planning proven optimal against Dijkstra; the warehouse provably offers two routes for the re-planning demo.</a:t>
+              <a:t>Validation is quantitative: kinematics error ≤ 1%, odometry drift ~2 cm, detector 100% on real frames, A* optimal vs Dijkstra.</a:t>
             </a:r>
             <a:endParaRPr lang="en-US" sz="1700" dirty="0"/>
           </a:p>
@@ -2624,7 +2624,7 @@
                 <a:ea typeface="Segoe UI" pitchFamily="34" charset="-122"/>
                 <a:cs typeface="Segoe UI" pitchFamily="34" charset="-120"/>
               </a:rPr>
-              <a:t>Remaining work is measurement, not construction: live Webots runs fill the evidence tables, then the final-eval features plug into tested hooks.</a:t>
+              <a:t>Next is coverage, not construction: the recording, lighting variants, the 10-run campaign — then final-eval features plug into tested hooks.</a:t>
             </a:r>
             <a:endParaRPr lang="en-US" sz="1700" dirty="0"/>
           </a:p>
@@ -4300,7 +4300,7 @@
                 <a:ea typeface="Segoe UI" pitchFamily="34" charset="-122"/>
                 <a:cs typeface="Segoe UI" pitchFamily="34" charset="-120"/>
               </a:rPr>
-              <a:t>controller.py</a:t>
+              <a:t>waypoint_follower.py</a:t>
             </a:r>
             <a:endParaRPr lang="en-US" sz="1300" dirty="0"/>
           </a:p>
@@ -5215,7 +5215,7 @@
                 <a:ea typeface="Segoe UI" pitchFamily="34" charset="-122"/>
                 <a:cs typeface="Segoe UI" pitchFamily="34" charset="-120"/>
               </a:rPr>
-              <a:t>controller.py — WaypointFollower</a:t>
+              <a:t>waypoint_follower.py — WaypointFollower</a:t>
             </a:r>
             <a:endParaRPr lang="en-US" sz="1200" dirty="0"/>
           </a:p>
@@ -5665,7 +5665,7 @@
                 <a:ea typeface="Segoe UI" pitchFamily="34" charset="-122"/>
                 <a:cs typeface="Segoe UI" pitchFamily="34" charset="-120"/>
               </a:rPr>
-              <a:t>3,476</a:t>
+              <a:t>4,299</a:t>
             </a:r>
             <a:endParaRPr lang="en-US" sz="3600" dirty="0"/>
           </a:p>
@@ -5743,7 +5743,7 @@
                 <a:ea typeface="Segoe UI" pitchFamily="34" charset="-122"/>
                 <a:cs typeface="Segoe UI" pitchFamily="34" charset="-120"/>
               </a:rPr>
-              <a:t>10</a:t>
+              <a:t>12</a:t>
             </a:r>
             <a:endParaRPr lang="en-US" sz="3600" dirty="0"/>
           </a:p>
@@ -5821,7 +5821,7 @@
                 <a:ea typeface="Segoe UI" pitchFamily="34" charset="-122"/>
                 <a:cs typeface="Segoe UI" pitchFamily="34" charset="-120"/>
               </a:rPr>
-              <a:t>7</a:t>
+              <a:t>8</a:t>
             </a:r>
             <a:endParaRPr lang="en-US" sz="3600" dirty="0"/>
           </a:p>
@@ -5899,7 +5899,7 @@
                 <a:ea typeface="Segoe UI" pitchFamily="34" charset="-122"/>
                 <a:cs typeface="Segoe UI" pitchFamily="34" charset="-120"/>
               </a:rPr>
-              <a:t>1</a:t>
+              <a:t>12</a:t>
             </a:r>
             <a:endParaRPr lang="en-US" sz="3600" dirty="0"/>
           </a:p>
@@ -5938,7 +5938,7 @@
                 <a:ea typeface="Segoe UI" pitchFamily="34" charset="-122"/>
                 <a:cs typeface="Segoe UI" pitchFamily="34" charset="-120"/>
               </a:rPr>
-              <a:t>generated world file</a:t>
+              <a:t>evidence artifacts</a:t>
             </a:r>
             <a:endParaRPr lang="en-US" sz="1200" dirty="0"/>
           </a:p>
@@ -8511,7 +8511,7 @@
         <p:spPr>
           <a:xfrm>
             <a:off x="685800" y="1691640"/>
-            <a:ext cx="5120640" cy="320040"/>
+            <a:ext cx="5212080" cy="320040"/>
           </a:xfrm>
           <a:prstGeom prst="rect">
             <a:avLst/>
@@ -8535,7 +8535,7 @@
                 <a:ea typeface="Segoe UI" pitchFamily="34" charset="-122"/>
                 <a:cs typeface="Segoe UI" pitchFamily="34" charset="-120"/>
               </a:rPr>
-              <a:t>Verified offline — pytest, 63/63 green</a:t>
+              <a:t>Measured on the robot + 63/63 pytest green</a:t>
             </a:r>
             <a:endParaRPr lang="en-US" sz="1500" dirty="0"/>
           </a:p>
@@ -8564,13 +8564,13 @@
           <a:p>
             <a:pPr algn="l" marL="152400" indent="-152400">
               <a:spcAft>
-                <a:spcPts val="900"/>
+                <a:spcPts val="800"/>
               </a:spcAft>
               <a:buSzPct val="100000"/>
               <a:buChar char="▸"/>
             </a:pPr>
             <a:r>
-              <a:rPr lang="en-US" sz="1250" dirty="0">
+              <a:rPr lang="en-US" sz="1200" dirty="0">
                 <a:solidFill>
                   <a:srgbClr val="1E293B"/>
                 </a:solidFill>
@@ -8578,20 +8578,20 @@
                 <a:ea typeface="Segoe UI" pitchFamily="34" charset="-122"/>
                 <a:cs typeface="Segoe UI" pitchFamily="34" charset="-120"/>
               </a:rPr>
-              <a:t>Kinematics: round-trip, curvature-preserving clamping, odometry on a known circle</a:t>
-            </a:r>
-            <a:endParaRPr lang="en-US" sz="1250" dirty="0"/>
+              <a:t>Kinematics error ≤ 1% on all four test commands (GPS/IMU truth)</a:t>
+            </a:r>
+            <a:endParaRPr lang="en-US" sz="1200" dirty="0"/>
           </a:p>
           <a:p>
             <a:pPr algn="l" marL="152400" indent="-152400">
               <a:spcAft>
-                <a:spcPts val="900"/>
+                <a:spcPts val="800"/>
               </a:spcAft>
               <a:buSzPct val="100000"/>
               <a:buChar char="▸"/>
             </a:pPr>
             <a:r>
-              <a:rPr lang="en-US" sz="1250" dirty="0">
+              <a:rPr lang="en-US" sz="1200" dirty="0">
                 <a:solidFill>
                   <a:srgbClr val="1E293B"/>
                 </a:solidFill>
@@ -8599,20 +8599,20 @@
                 <a:ea typeface="Segoe UI" pitchFamily="34" charset="-122"/>
                 <a:cs typeface="Segoe UI" pitchFamily="34" charset="-120"/>
               </a:rPr>
-              <a:t>A* cost == Dijkstra on 60 random grids; corner-cutting impossible</a:t>
-            </a:r>
-            <a:endParaRPr lang="en-US" sz="1250" dirty="0"/>
+              <a:t>Odometry drift: 2.2 cm / 4.7° over the 2 m square; ~1 cm on line and arc</a:t>
+            </a:r>
+            <a:endParaRPr lang="en-US" sz="1200" dirty="0"/>
           </a:p>
           <a:p>
             <a:pPr algn="l" marL="152400" indent="-152400">
               <a:spcAft>
-                <a:spcPts val="900"/>
+                <a:spcPts val="800"/>
               </a:spcAft>
               <a:buSzPct val="100000"/>
               <a:buChar char="▸"/>
             </a:pPr>
             <a:r>
-              <a:rPr lang="en-US" sz="1250" dirty="0">
+              <a:rPr lang="en-US" sz="1200" dirty="0">
                 <a:solidFill>
                   <a:srgbClr val="1E293B"/>
                 </a:solidFill>
@@ -8620,20 +8620,20 @@
                 <a:ea typeface="Segoe UI" pitchFamily="34" charset="-122"/>
                 <a:cs typeface="Segoe UI" pitchFamily="34" charset="-120"/>
               </a:rPr>
-              <a:t>Real layout: pickup → Zone B path + two distinct routes</a:t>
-            </a:r>
-            <a:endParaRPr lang="en-US" sz="1250" dirty="0"/>
+              <a:t>FULL MISSION RAN IN WEBOTS: FIND → NAVIGATE → PICK → PLAN → DELIVER → DONE (69 s, 12 obstacles); cross-track max 6.2 cm</a:t>
+            </a:r>
+            <a:endParaRPr lang="en-US" sz="1200" dirty="0"/>
           </a:p>
           <a:p>
             <a:pPr algn="l" marL="152400" indent="-152400">
               <a:spcAft>
-                <a:spcPts val="900"/>
+                <a:spcPts val="800"/>
               </a:spcAft>
               <a:buSzPct val="100000"/>
               <a:buChar char="▸"/>
             </a:pPr>
             <a:r>
-              <a:rPr lang="en-US" sz="1250" dirty="0">
+              <a:rPr lang="en-US" sz="1200" dirty="0">
                 <a:solidFill>
                   <a:srgbClr val="1E293B"/>
                 </a:solidFill>
@@ -8641,20 +8641,20 @@
                 <a:ea typeface="Segoe UI" pitchFamily="34" charset="-122"/>
                 <a:cs typeface="Segoe UI" pitchFamily="34" charset="-120"/>
               </a:rPr>
-              <a:t>FSM happy path IDLE → … → DONE incl. mission report; ERROR paths</a:t>
-            </a:r>
-            <a:endParaRPr lang="en-US" sz="1250" dirty="0"/>
+              <a:t>LiDAR ray order MEASURED: index runs clockwise (SIGN=−1) — fixed the 0.6 m estimate bug → now 0.13 m; range accuracy 8 cm median</a:t>
+            </a:r>
+            <a:endParaRPr lang="en-US" sz="1200" dirty="0"/>
           </a:p>
           <a:p>
             <a:pPr algn="l" marL="152400" indent="-152400">
               <a:spcAft>
-                <a:spcPts val="900"/>
+                <a:spcPts val="800"/>
               </a:spcAft>
               <a:buSzPct val="100000"/>
               <a:buChar char="▸"/>
             </a:pPr>
             <a:r>
-              <a:rPr lang="en-US" sz="1250" dirty="0">
+              <a:rPr lang="en-US" sz="1200" dirty="0">
                 <a:solidFill>
                   <a:srgbClr val="1E293B"/>
                 </a:solidFill>
@@ -8662,20 +8662,20 @@
                 <a:ea typeface="Segoe UI" pitchFamily="34" charset="-122"/>
                 <a:cs typeface="Segoe UI" pitchFamily="34" charset="-120"/>
               </a:rPr>
-              <a:t>Detector: correct colors/bboxes; zone hues never misfired</a:t>
-            </a:r>
-            <a:endParaRPr lang="en-US" sz="1250" dirty="0"/>
+              <a:t>A* cost == Dijkstra on 60 random grids; two routes verified</a:t>
+            </a:r>
+            <a:endParaRPr lang="en-US" sz="1200" dirty="0"/>
           </a:p>
           <a:p>
             <a:pPr algn="l" marL="152400" indent="-152400">
               <a:spcAft>
-                <a:spcPts val="900"/>
+                <a:spcPts val="800"/>
               </a:spcAft>
               <a:buSzPct val="100000"/>
               <a:buChar char="▸"/>
             </a:pPr>
             <a:r>
-              <a:rPr lang="en-US" sz="1250" dirty="0">
+              <a:rPr lang="en-US" sz="1200" dirty="0">
                 <a:solidFill>
                   <a:srgbClr val="1E293B"/>
                 </a:solidFill>
@@ -8685,7 +8685,7 @@
               </a:rPr>
               <a:t>Re-plan hooks: blocked route detected → alternate route planned</a:t>
             </a:r>
-            <a:endParaRPr lang="en-US" sz="1250" dirty="0"/>
+            <a:endParaRPr lang="en-US" sz="1200" dirty="0"/>
           </a:p>
         </p:txBody>
       </p:sp>
@@ -8751,7 +8751,7 @@
                 <a:ea typeface="Segoe UI" pitchFamily="34" charset="-122"/>
                 <a:cs typeface="Segoe UI" pitchFamily="34" charset="-120"/>
               </a:rPr>
-              <a:t>Pending live Webots runs (exact commands in README)</a:t>
+              <a:t>Still to measure (tooling ready, commands in README)</a:t>
             </a:r>
             <a:endParaRPr lang="en-US" sz="1500" dirty="0"/>
           </a:p>
@@ -8766,7 +8766,7 @@
         <p:spPr>
           <a:xfrm>
             <a:off x="6446520" y="2103120"/>
-            <a:ext cx="5074920" cy="2743200"/>
+            <a:ext cx="5074920" cy="1463040"/>
           </a:xfrm>
           <a:prstGeom prst="rect">
             <a:avLst/>
@@ -8780,13 +8780,13 @@
           <a:p>
             <a:pPr algn="l" marL="152400" indent="-152400">
               <a:spcAft>
-                <a:spcPts val="900"/>
+                <a:spcPts val="700"/>
               </a:spcAft>
               <a:buSzPct val="100000"/>
               <a:buChar char="▸"/>
             </a:pPr>
             <a:r>
-              <a:rPr lang="en-US" sz="1250" dirty="0">
+              <a:rPr lang="en-US" sz="1200" dirty="0">
                 <a:solidFill>
                   <a:srgbClr val="1E293B"/>
                 </a:solidFill>
@@ -8794,20 +8794,20 @@
                 <a:ea typeface="Segoe UI" pitchFamily="34" charset="-122"/>
                 <a:cs typeface="Segoe UI" pitchFamily="34" charset="-120"/>
               </a:rPr>
-              <a:t>Kinematics error % — commanded vs GPS/IMU finite differences (drive_test)</a:t>
-            </a:r>
-            <a:endParaRPr lang="en-US" sz="1250" dirty="0"/>
+              <a:t>Repeatability: ≥10 runs from different starts (RUN_INDEX mode wired)</a:t>
+            </a:r>
+            <a:endParaRPr lang="en-US" sz="1200" dirty="0"/>
           </a:p>
           <a:p>
             <a:pPr algn="l" marL="152400" indent="-152400">
               <a:spcAft>
-                <a:spcPts val="900"/>
+                <a:spcPts val="700"/>
               </a:spcAft>
               <a:buSzPct val="100000"/>
               <a:buChar char="▸"/>
             </a:pPr>
             <a:r>
-              <a:rPr lang="en-US" sz="1250" dirty="0">
+              <a:rPr lang="en-US" sz="1200" dirty="0">
                 <a:solidFill>
                   <a:srgbClr val="1E293B"/>
                 </a:solidFill>
@@ -8815,20 +8815,20 @@
                 <a:ea typeface="Segoe UI" pitchFamily="34" charset="-122"/>
                 <a:cs typeface="Segoe UI" pitchFamily="34" charset="-120"/>
               </a:rPr>
-              <a:t>Odometry drift vs GPS on line / square / arc</a:t>
-            </a:r>
-            <a:endParaRPr lang="en-US" sz="1250" dirty="0"/>
+              <a:t>≤60 s screen recording of the full run (Webots Movie mode)</a:t>
+            </a:r>
+            <a:endParaRPr lang="en-US" sz="1200" dirty="0"/>
           </a:p>
           <a:p>
             <a:pPr algn="l" marL="152400" indent="-152400">
               <a:spcAft>
-                <a:spcPts val="900"/>
+                <a:spcPts val="700"/>
               </a:spcAft>
               <a:buSzPct val="100000"/>
               <a:buChar char="▸"/>
             </a:pPr>
             <a:r>
-              <a:rPr lang="en-US" sz="1250" dirty="0">
+              <a:rPr lang="en-US" sz="1200" dirty="0">
                 <a:solidFill>
                   <a:srgbClr val="1E293B"/>
                 </a:solidFill>
@@ -8836,20 +8836,52 @@
                 <a:ea typeface="Segoe UI" pitchFamily="34" charset="-122"/>
                 <a:cs typeface="Segoe UI" pitchFamily="34" charset="-120"/>
               </a:rPr>
-              <a:t>LiDAR ray-order calibration (left-only obstacle) + range accuracy at 0.5/1/2 m</a:t>
-            </a:r>
-            <a:endParaRPr lang="en-US" sz="1250" dirty="0"/>
-          </a:p>
-          <a:p>
-            <a:pPr algn="l" marL="152400" indent="-152400">
-              <a:spcAft>
-                <a:spcPts val="900"/>
-              </a:spcAft>
-              <a:buSzPct val="100000"/>
-              <a:buChar char="▸"/>
-            </a:pPr>
-            <a:r>
-              <a:rPr lang="en-US" sz="1250" dirty="0">
+              <a:t>Detector lighting variants + more distances (13-frame sample today)</a:t>
+            </a:r>
+            <a:endParaRPr lang="en-US" sz="1200" dirty="0"/>
+          </a:p>
+        </p:txBody>
+      </p:sp>
+      <p:sp>
+        <p:nvSpPr>
+          <p:cNvPr id="10" name="Text 8"/>
+          <p:cNvSpPr/>
+          <p:nvPr/>
+        </p:nvSpPr>
+        <p:spPr>
+          <a:xfrm>
+            <a:off x="6446520" y="3931920"/>
+            <a:ext cx="5120640" cy="1645920"/>
+          </a:xfrm>
+          <a:prstGeom prst="rect">
+            <a:avLst/>
+          </a:prstGeom>
+          <a:noFill/>
+          <a:ln/>
+        </p:spPr>
+        <p:txBody>
+          <a:bodyPr wrap="square" lIns="0" tIns="0" rIns="0" bIns="0" rtlCol="0" anchor="ctr"/>
+          <a:lstStyle/>
+          <a:p>
+            <a:pPr indent="0" marL="0">
+              <a:buNone/>
+            </a:pPr>
+            <a:r>
+              <a:rPr lang="en-US" sz="1050" b="1" dirty="0">
+                <a:solidFill>
+                  <a:srgbClr val="EA580C"/>
+                </a:solidFill>
+                <a:latin typeface="Segoe UI" pitchFamily="34" charset="0"/>
+                <a:ea typeface="Segoe UI" pitchFamily="34" charset="-122"/>
+                <a:cs typeface="Segoe UI" pitchFamily="34" charset="-120"/>
+              </a:rPr>
+              <a:t>Real challenges hit &amp; fixed: </a:t>
+            </a:r>
+            <a:pPr indent="0" marL="0">
+              <a:buNone/>
+            </a:pPr>
+            <a:r>
+              <a:rPr lang="en-US" sz="1050" dirty="0">
                 <a:solidFill>
                   <a:srgbClr val="1E293B"/>
                 </a:solidFill>
@@ -8857,83 +8889,9 @@
                 <a:ea typeface="Segoe UI" pitchFamily="34" charset="-122"/>
                 <a:cs typeface="Segoe UI" pitchFamily="34" charset="-120"/>
               </a:rPr>
-              <a:t>Detector rates on REAL frames + lighting variants</a:t>
-            </a:r>
-            <a:endParaRPr lang="en-US" sz="1250" dirty="0"/>
-          </a:p>
-          <a:p>
-            <a:pPr algn="l" marL="152400" indent="-152400">
-              <a:spcAft>
-                <a:spcPts val="900"/>
-              </a:spcAft>
-              <a:buSzPct val="100000"/>
-              <a:buChar char="▸"/>
-            </a:pPr>
-            <a:r>
-              <a:rPr lang="en-US" sz="1250" dirty="0">
-                <a:solidFill>
-                  <a:srgbClr val="1E293B"/>
-                </a:solidFill>
-                <a:latin typeface="Segoe UI" pitchFamily="34" charset="0"/>
-                <a:ea typeface="Segoe UI" pitchFamily="34" charset="-122"/>
-                <a:cs typeface="Segoe UI" pitchFamily="34" charset="-120"/>
-              </a:rPr>
-              <a:t>Cross-track error, success rate over ≥10 runs, screen recording</a:t>
-            </a:r>
-            <a:endParaRPr lang="en-US" sz="1250" dirty="0"/>
-          </a:p>
-        </p:txBody>
-      </p:sp>
-      <p:sp>
-        <p:nvSpPr>
-          <p:cNvPr id="10" name="Text 8"/>
-          <p:cNvSpPr/>
-          <p:nvPr/>
-        </p:nvSpPr>
-        <p:spPr>
-          <a:xfrm>
-            <a:off x="6446520" y="4572000"/>
-            <a:ext cx="5120640" cy="1005840"/>
-          </a:xfrm>
-          <a:prstGeom prst="rect">
-            <a:avLst/>
-          </a:prstGeom>
-          <a:noFill/>
-          <a:ln/>
-        </p:spPr>
-        <p:txBody>
-          <a:bodyPr wrap="square" lIns="0" tIns="0" rIns="0" bIns="0" rtlCol="0" anchor="ctr"/>
-          <a:lstStyle/>
-          <a:p>
-            <a:pPr indent="0" marL="0">
-              <a:buNone/>
-            </a:pPr>
-            <a:r>
-              <a:rPr lang="en-US" sz="1150" b="1" dirty="0">
-                <a:solidFill>
-                  <a:srgbClr val="EA580C"/>
-                </a:solidFill>
-                <a:latin typeface="Segoe UI" pitchFamily="34" charset="0"/>
-                <a:ea typeface="Segoe UI" pitchFamily="34" charset="-122"/>
-                <a:cs typeface="Segoe UI" pitchFamily="34" charset="-120"/>
-              </a:rPr>
-              <a:t>Challenge hit &amp; fixed: </a:t>
-            </a:r>
-            <a:pPr indent="0" marL="0">
-              <a:buNone/>
-            </a:pPr>
-            <a:r>
-              <a:rPr lang="en-US" sz="1150" dirty="0">
-                <a:solidFill>
-                  <a:srgbClr val="1E293B"/>
-                </a:solidFill>
-                <a:latin typeface="Segoe UI" pitchFamily="34" charset="0"/>
-                <a:ea typeface="Segoe UI" pitchFamily="34" charset="-122"/>
-                <a:cs typeface="Segoe UI" pitchFamily="34" charset="-120"/>
-              </a:rPr>
-              <a:t>the first anti-windup scheme (back-calculation with kᵢ = 0.05) produced ±40 integral jumps and stalled the heading controller; replaced with conditional integration — follower then completed multi-waypoint paths.</a:t>
-            </a:r>
-            <a:endParaRPr lang="en-US" sz="1150" dirty="0"/>
+              <a:t>cylinder wheel contact widened the effective track (−14% yaw rate) — fixed with sphere wheel bounding objects; a single light left package faces at HSV V≈46 — fixed with two opposed lights; a blue decorative ball was mistaken for package P3 — desaturated; LiDAR ray order was mirrored — measured against the known map and corrected.</a:t>
+            </a:r>
+            <a:endParaRPr lang="en-US" sz="1050" dirty="0"/>
           </a:p>
         </p:txBody>
       </p:sp>
@@ -8970,7 +8928,7 @@
                 <a:ea typeface="Segoe UI" pitchFamily="34" charset="-122"/>
                 <a:cs typeface="Segoe UI" pitchFamily="34" charset="-120"/>
               </a:rPr>
-              <a:t>No simulation result is claimed without being observed — the build machine has no Webots install, so sim-dependent numbers stay honestly pending.</a:t>
+              <a:t>Every number above points to a file in docs/evidence/ — claims without artifacts stay out of the deck.</a:t>
             </a:r>
             <a:endParaRPr lang="en-US" sz="1200" dirty="0"/>
           </a:p>
@@ -9696,7 +9654,7 @@
                 <a:ea typeface="Segoe UI" pitchFamily="34" charset="-122"/>
                 <a:cs typeface="Segoe UI" pitchFamily="34" charset="-120"/>
               </a:rPr>
-              <a:t>Run the live validation suite; capture evidence (recordings, metrics)</a:t>
+              <a:t>Finish P0 evidence: LiDAR calibration, detector set, ≤60 s recording</a:t>
             </a:r>
             <a:endParaRPr lang="en-US" sz="1350" dirty="0"/>
           </a:p>
@@ -9796,7 +9754,7 @@
                 <a:ea typeface="Segoe UI" pitchFamily="34" charset="-122"/>
                 <a:cs typeface="Segoe UI" pitchFamily="34" charset="-120"/>
               </a:rPr>
-              <a:t>Tune PID gains on the real robot; ≥10-run success-rate campaign</a:t>
+              <a:t>10-run repeatability campaign (RUN_INDEX mode wired); detector lighting set</a:t>
             </a:r>
             <a:endParaRPr lang="en-US" sz="1350" dirty="0"/>
           </a:p>

</xml_diff>